<commit_message>
1st 3 slides ingevuld en aangepast
</commit_message>
<xml_diff>
--- a/Presentatie QR-code.pptx
+++ b/Presentatie QR-code.pptx
@@ -108,6 +108,11 @@
       </a:defRPr>
     </a:lvl9pPr>
   </p:defaultTextStyle>
+  <p:extLst>
+    <p:ext uri="{EFAFB233-063F-42B5-8137-9DF3F51BA10A}">
+      <p15:sldGuideLst xmlns:p15="http://schemas.microsoft.com/office/powerpoint/2012/main"/>
+    </p:ext>
+  </p:extLst>
 </p:presentation>
 </file>
 
@@ -1520,7 +1525,7 @@
           <a:p>
             <a:fld id="{69D543F8-9B03-4A62-AE01-676F05C7E2EC}" type="datetimeFigureOut">
               <a:rPr lang="en-BE" smtClean="0"/>
-              <a:t>15/12/2025</a:t>
+              <a:t>05/01/2026</a:t>
             </a:fld>
             <a:endParaRPr lang="en-BE"/>
           </a:p>
@@ -2979,7 +2984,7 @@
           <a:p>
             <a:fld id="{69D543F8-9B03-4A62-AE01-676F05C7E2EC}" type="datetimeFigureOut">
               <a:rPr lang="en-BE" smtClean="0"/>
-              <a:t>15/12/2025</a:t>
+              <a:t>05/01/2026</a:t>
             </a:fld>
             <a:endParaRPr lang="en-BE"/>
           </a:p>
@@ -4432,7 +4437,7 @@
           <a:p>
             <a:fld id="{69D543F8-9B03-4A62-AE01-676F05C7E2EC}" type="datetimeFigureOut">
               <a:rPr lang="en-BE" smtClean="0"/>
-              <a:t>15/12/2025</a:t>
+              <a:t>05/01/2026</a:t>
             </a:fld>
             <a:endParaRPr lang="en-BE"/>
           </a:p>
@@ -5887,7 +5892,7 @@
           <a:p>
             <a:fld id="{69D543F8-9B03-4A62-AE01-676F05C7E2EC}" type="datetimeFigureOut">
               <a:rPr lang="en-BE" smtClean="0"/>
-              <a:t>15/12/2025</a:t>
+              <a:t>05/01/2026</a:t>
             </a:fld>
             <a:endParaRPr lang="en-BE"/>
           </a:p>
@@ -7395,7 +7400,7 @@
           <a:p>
             <a:fld id="{69D543F8-9B03-4A62-AE01-676F05C7E2EC}" type="datetimeFigureOut">
               <a:rPr lang="en-BE" smtClean="0"/>
-              <a:t>15/12/2025</a:t>
+              <a:t>05/01/2026</a:t>
             </a:fld>
             <a:endParaRPr lang="en-BE"/>
           </a:p>
@@ -8916,7 +8921,7 @@
           <a:p>
             <a:fld id="{69D543F8-9B03-4A62-AE01-676F05C7E2EC}" type="datetimeFigureOut">
               <a:rPr lang="en-BE" smtClean="0"/>
-              <a:t>15/12/2025</a:t>
+              <a:t>05/01/2026</a:t>
             </a:fld>
             <a:endParaRPr lang="en-BE"/>
           </a:p>
@@ -10581,7 +10586,7 @@
           <a:p>
             <a:fld id="{69D543F8-9B03-4A62-AE01-676F05C7E2EC}" type="datetimeFigureOut">
               <a:rPr lang="en-BE" smtClean="0"/>
-              <a:t>15/12/2025</a:t>
+              <a:t>05/01/2026</a:t>
             </a:fld>
             <a:endParaRPr lang="en-BE"/>
           </a:p>
@@ -11979,7 +11984,7 @@
           <a:p>
             <a:fld id="{69D543F8-9B03-4A62-AE01-676F05C7E2EC}" type="datetimeFigureOut">
               <a:rPr lang="en-BE" smtClean="0"/>
-              <a:t>15/12/2025</a:t>
+              <a:t>05/01/2026</a:t>
             </a:fld>
             <a:endParaRPr lang="en-BE"/>
           </a:p>
@@ -12079,7 +12084,7 @@
           <a:p>
             <a:fld id="{69D543F8-9B03-4A62-AE01-676F05C7E2EC}" type="datetimeFigureOut">
               <a:rPr lang="en-BE" smtClean="0"/>
-              <a:t>15/12/2025</a:t>
+              <a:t>05/01/2026</a:t>
             </a:fld>
             <a:endParaRPr lang="en-BE"/>
           </a:p>
@@ -13605,7 +13610,7 @@
           <a:p>
             <a:fld id="{69D543F8-9B03-4A62-AE01-676F05C7E2EC}" type="datetimeFigureOut">
               <a:rPr lang="en-BE" smtClean="0"/>
-              <a:t>15/12/2025</a:t>
+              <a:t>05/01/2026</a:t>
             </a:fld>
             <a:endParaRPr lang="en-BE"/>
           </a:p>
@@ -15141,7 +15146,7 @@
           <a:p>
             <a:fld id="{69D543F8-9B03-4A62-AE01-676F05C7E2EC}" type="datetimeFigureOut">
               <a:rPr lang="en-BE" smtClean="0"/>
-              <a:t>15/12/2025</a:t>
+              <a:t>05/01/2026</a:t>
             </a:fld>
             <a:endParaRPr lang="en-BE"/>
           </a:p>
@@ -15364,7 +15369,7 @@
           <a:p>
             <a:fld id="{69D543F8-9B03-4A62-AE01-676F05C7E2EC}" type="datetimeFigureOut">
               <a:rPr lang="en-BE" smtClean="0"/>
-              <a:t>15/12/2025</a:t>
+              <a:t>05/01/2026</a:t>
             </a:fld>
             <a:endParaRPr lang="en-BE"/>
           </a:p>
@@ -15815,42 +15820,84 @@
           <a:chExt cx="0" cy="0"/>
         </a:xfrm>
       </p:grpSpPr>
-      <p:pic>
-        <p:nvPicPr>
-          <p:cNvPr id="5" name="Picture 4">
+      <p:sp>
+        <p:nvSpPr>
+          <p:cNvPr id="2" name="Title 1">
             <a:extLst>
               <a:ext uri="{FF2B5EF4-FFF2-40B4-BE49-F238E27FC236}">
-                <a16:creationId xmlns:a16="http://schemas.microsoft.com/office/drawing/2014/main" id="{562A6B7D-4F26-02A5-A891-603EF9EFA3A1}"/>
+                <a16:creationId xmlns:a16="http://schemas.microsoft.com/office/drawing/2014/main" id="{5395E5C1-46B1-4C69-5334-9C0FEB2244B0}"/>
               </a:ext>
             </a:extLst>
           </p:cNvPr>
-          <p:cNvPicPr>
-            <a:picLocks noChangeAspect="1"/>
-          </p:cNvPicPr>
-          <p:nvPr/>
-        </p:nvPicPr>
-        <p:blipFill>
-          <a:blip r:embed="rId2">
-            <a:extLst>
-              <a:ext uri="{28A0092B-C50C-407E-A947-70E740481C1C}">
-                <a14:useLocalDpi xmlns:a14="http://schemas.microsoft.com/office/drawing/2010/main" val="0"/>
-              </a:ext>
-            </a:extLst>
-          </a:blip>
-          <a:stretch>
-            <a:fillRect/>
-          </a:stretch>
-        </p:blipFill>
-        <p:spPr>
-          <a:xfrm>
-            <a:off x="3064522" y="446204"/>
-            <a:ext cx="5220739" cy="5663313"/>
-          </a:xfrm>
-          <a:prstGeom prst="rect">
-            <a:avLst/>
-          </a:prstGeom>
-        </p:spPr>
-      </p:pic>
+          <p:cNvSpPr>
+            <a:spLocks noGrp="1"/>
+          </p:cNvSpPr>
+          <p:nvPr>
+            <p:ph type="ctrTitle"/>
+          </p:nvPr>
+        </p:nvSpPr>
+        <p:spPr/>
+        <p:txBody>
+          <a:bodyPr/>
+          <a:lstStyle/>
+          <a:p>
+            <a:r>
+              <a:rPr lang="en-GB" dirty="0" err="1"/>
+              <a:t>Waar</a:t>
+            </a:r>
+            <a:r>
+              <a:rPr lang="en-GB" dirty="0"/>
+              <a:t> </a:t>
+            </a:r>
+            <a:r>
+              <a:rPr lang="en-GB" dirty="0" err="1"/>
+              <a:t>staat</a:t>
+            </a:r>
+            <a:r>
+              <a:rPr lang="en-GB" dirty="0"/>
+              <a:t> QR </a:t>
+            </a:r>
+            <a:r>
+              <a:rPr lang="en-GB" dirty="0" err="1"/>
+              <a:t>voor</a:t>
+            </a:r>
+            <a:r>
+              <a:rPr lang="en-GB" dirty="0"/>
+              <a:t>?</a:t>
+            </a:r>
+            <a:endParaRPr lang="en-BE" dirty="0"/>
+          </a:p>
+        </p:txBody>
+      </p:sp>
+      <p:sp>
+        <p:nvSpPr>
+          <p:cNvPr id="3" name="Subtitle 2">
+            <a:extLst>
+              <a:ext uri="{FF2B5EF4-FFF2-40B4-BE49-F238E27FC236}">
+                <a16:creationId xmlns:a16="http://schemas.microsoft.com/office/drawing/2014/main" id="{08D69AC9-3D2E-9340-AA91-7E9AAB86876C}"/>
+              </a:ext>
+            </a:extLst>
+          </p:cNvPr>
+          <p:cNvSpPr>
+            <a:spLocks noGrp="1"/>
+          </p:cNvSpPr>
+          <p:nvPr>
+            <p:ph type="subTitle" idx="1"/>
+          </p:nvPr>
+        </p:nvSpPr>
+        <p:spPr/>
+        <p:txBody>
+          <a:bodyPr/>
+          <a:lstStyle/>
+          <a:p>
+            <a:r>
+              <a:rPr lang="en-GB" dirty="0"/>
+              <a:t>Quick response</a:t>
+            </a:r>
+            <a:endParaRPr lang="en-BE" dirty="0"/>
+          </a:p>
+        </p:txBody>
+      </p:sp>
     </p:spTree>
     <p:extLst>
       <p:ext uri="{BB962C8B-B14F-4D97-AF65-F5344CB8AC3E}">
@@ -15938,6 +15985,211 @@
         <p:txBody>
           <a:bodyPr/>
           <a:lstStyle/>
+          <a:p>
+            <a:r>
+              <a:rPr lang="en-GB" dirty="0" err="1"/>
+              <a:t>Een</a:t>
+            </a:r>
+            <a:r>
+              <a:rPr lang="en-GB" dirty="0"/>
+              <a:t> </a:t>
+            </a:r>
+            <a:r>
+              <a:rPr lang="en-GB" dirty="0" err="1"/>
+              <a:t>tweedimensionale</a:t>
+            </a:r>
+            <a:r>
+              <a:rPr lang="en-GB" dirty="0"/>
+              <a:t> barcode.</a:t>
+            </a:r>
+          </a:p>
+          <a:p>
+            <a:pPr marL="0" indent="0">
+              <a:buNone/>
+            </a:pPr>
+            <a:endParaRPr lang="en-GB" dirty="0"/>
+          </a:p>
+          <a:p>
+            <a:r>
+              <a:rPr lang="en-GB" dirty="0" err="1"/>
+              <a:t>Vierkant</a:t>
+            </a:r>
+            <a:r>
+              <a:rPr lang="en-GB" dirty="0"/>
+              <a:t> </a:t>
+            </a:r>
+            <a:r>
+              <a:rPr lang="en-GB" dirty="0" err="1"/>
+              <a:t>bestaande</a:t>
+            </a:r>
+            <a:r>
+              <a:rPr lang="en-GB" dirty="0"/>
+              <a:t> </a:t>
+            </a:r>
+            <a:r>
+              <a:rPr lang="en-GB" dirty="0" err="1"/>
+              <a:t>uit</a:t>
+            </a:r>
+            <a:r>
+              <a:rPr lang="en-GB" dirty="0"/>
+              <a:t> </a:t>
+            </a:r>
+            <a:r>
+              <a:rPr lang="en-GB" dirty="0" err="1"/>
+              <a:t>rijen</a:t>
+            </a:r>
+            <a:r>
+              <a:rPr lang="en-GB" dirty="0"/>
+              <a:t> en </a:t>
+            </a:r>
+            <a:r>
+              <a:rPr lang="en-GB" dirty="0" err="1"/>
+              <a:t>kolommen</a:t>
+            </a:r>
+            <a:r>
+              <a:rPr lang="en-GB" dirty="0"/>
+              <a:t>.</a:t>
+            </a:r>
+          </a:p>
+          <a:p>
+            <a:endParaRPr lang="en-GB" dirty="0"/>
+          </a:p>
+          <a:p>
+            <a:r>
+              <a:rPr lang="en-GB" dirty="0"/>
+              <a:t>Kleine </a:t>
+            </a:r>
+            <a:r>
+              <a:rPr lang="en-GB" dirty="0" err="1"/>
+              <a:t>zwarte</a:t>
+            </a:r>
+            <a:r>
+              <a:rPr lang="en-GB" dirty="0"/>
+              <a:t> en </a:t>
+            </a:r>
+            <a:r>
+              <a:rPr lang="en-GB" dirty="0" err="1"/>
+              <a:t>witte</a:t>
+            </a:r>
+            <a:r>
+              <a:rPr lang="en-GB" dirty="0"/>
+              <a:t> </a:t>
+            </a:r>
+            <a:r>
+              <a:rPr lang="en-GB" dirty="0" err="1"/>
+              <a:t>vierkantjes</a:t>
+            </a:r>
+            <a:r>
+              <a:rPr lang="en-GB" dirty="0"/>
+              <a:t>.</a:t>
+            </a:r>
+          </a:p>
+          <a:p>
+            <a:endParaRPr lang="en-GB" dirty="0"/>
+          </a:p>
+          <a:p>
+            <a:r>
+              <a:rPr lang="en-GB" dirty="0"/>
+              <a:t>In ¾ </a:t>
+            </a:r>
+            <a:r>
+              <a:rPr lang="en-GB" dirty="0" err="1"/>
+              <a:t>hoekpunten</a:t>
+            </a:r>
+            <a:r>
+              <a:rPr lang="en-GB" dirty="0"/>
+              <a:t> </a:t>
+            </a:r>
+            <a:r>
+              <a:rPr lang="en-GB" b="0" i="0" dirty="0" err="1">
+                <a:solidFill>
+                  <a:srgbClr val="202122"/>
+                </a:solidFill>
+                <a:effectLst/>
+                <a:latin typeface="Arial" panose="020B0604020202020204" pitchFamily="34" charset="0"/>
+              </a:rPr>
+              <a:t>oriënteringssymbool</a:t>
+            </a:r>
+            <a:r>
+              <a:rPr lang="en-GB" b="0" i="0" dirty="0">
+                <a:solidFill>
+                  <a:srgbClr val="202122"/>
+                </a:solidFill>
+                <a:effectLst/>
+                <a:latin typeface="Arial" panose="020B0604020202020204" pitchFamily="34" charset="0"/>
+              </a:rPr>
+              <a:t>.</a:t>
+            </a:r>
+          </a:p>
+          <a:p>
+            <a:pPr marL="0" indent="0">
+              <a:buNone/>
+            </a:pPr>
+            <a:endParaRPr lang="en-GB" b="0" i="0" dirty="0">
+              <a:solidFill>
+                <a:srgbClr val="202122"/>
+              </a:solidFill>
+              <a:effectLst/>
+              <a:latin typeface="Arial" panose="020B0604020202020204" pitchFamily="34" charset="0"/>
+            </a:endParaRPr>
+          </a:p>
+          <a:p>
+            <a:r>
+              <a:rPr lang="en-GB" dirty="0" err="1">
+                <a:solidFill>
+                  <a:srgbClr val="202122"/>
+                </a:solidFill>
+                <a:latin typeface="Arial" panose="020B0604020202020204" pitchFamily="34" charset="0"/>
+              </a:rPr>
+              <a:t>Rustzone</a:t>
+            </a:r>
+            <a:r>
+              <a:rPr lang="en-GB" dirty="0">
+                <a:solidFill>
+                  <a:srgbClr val="202122"/>
+                </a:solidFill>
+                <a:latin typeface="Arial" panose="020B0604020202020204" pitchFamily="34" charset="0"/>
+              </a:rPr>
+              <a:t>, 4 </a:t>
+            </a:r>
+            <a:r>
+              <a:rPr lang="en-GB" dirty="0" err="1">
+                <a:solidFill>
+                  <a:srgbClr val="202122"/>
+                </a:solidFill>
+                <a:latin typeface="Arial" panose="020B0604020202020204" pitchFamily="34" charset="0"/>
+              </a:rPr>
+              <a:t>blokje</a:t>
+            </a:r>
+            <a:r>
+              <a:rPr lang="en-GB" dirty="0">
+                <a:solidFill>
+                  <a:srgbClr val="202122"/>
+                </a:solidFill>
+                <a:latin typeface="Arial" panose="020B0604020202020204" pitchFamily="34" charset="0"/>
+              </a:rPr>
+              <a:t> brede </a:t>
+            </a:r>
+            <a:r>
+              <a:rPr lang="en-GB" dirty="0" err="1">
+                <a:solidFill>
+                  <a:srgbClr val="202122"/>
+                </a:solidFill>
+                <a:latin typeface="Arial" panose="020B0604020202020204" pitchFamily="34" charset="0"/>
+              </a:rPr>
+              <a:t>witte</a:t>
+            </a:r>
+            <a:r>
+              <a:rPr lang="en-GB" dirty="0">
+                <a:solidFill>
+                  <a:srgbClr val="202122"/>
+                </a:solidFill>
+                <a:latin typeface="Arial" panose="020B0604020202020204" pitchFamily="34" charset="0"/>
+              </a:rPr>
+              <a:t> strook.</a:t>
+            </a:r>
+            <a:endParaRPr lang="en-GB" dirty="0"/>
+          </a:p>
           <a:p>
             <a:endParaRPr lang="en-BE" dirty="0"/>
           </a:p>
@@ -16038,37 +16290,182 @@
             <p:ph sz="half" idx="1"/>
           </p:nvPr>
         </p:nvSpPr>
-        <p:spPr/>
+        <p:spPr>
+          <a:xfrm>
+            <a:off x="5097024" y="413468"/>
+            <a:ext cx="6269591" cy="6281529"/>
+          </a:xfrm>
+        </p:spPr>
         <p:txBody>
           <a:bodyPr/>
           <a:lstStyle/>
           <a:p>
-            <a:endParaRPr lang="en-BE"/>
+            <a:r>
+              <a:rPr lang="nl-NL" b="1" i="0" dirty="0">
+                <a:effectLst/>
+                <a:latin typeface="Google Sans"/>
+              </a:rPr>
+              <a:t>Betalingen:</a:t>
+            </a:r>
+            <a:r>
+              <a:rPr lang="nl-NL" b="0" i="0" dirty="0">
+                <a:effectLst/>
+                <a:latin typeface="Google Sans"/>
+              </a:rPr>
+              <a:t> Voor snelle betalingen in apps.</a:t>
+            </a:r>
           </a:p>
-        </p:txBody>
-      </p:sp>
-      <p:sp>
-        <p:nvSpPr>
-          <p:cNvPr id="4" name="Content Placeholder 3">
-            <a:extLst>
-              <a:ext uri="{FF2B5EF4-FFF2-40B4-BE49-F238E27FC236}">
-                <a16:creationId xmlns:a16="http://schemas.microsoft.com/office/drawing/2014/main" id="{35A4FAF7-2CC9-A892-D5C6-86E988B6EC0B}"/>
-              </a:ext>
-            </a:extLst>
-          </p:cNvPr>
-          <p:cNvSpPr>
-            <a:spLocks noGrp="1"/>
-          </p:cNvSpPr>
-          <p:nvPr>
-            <p:ph sz="half" idx="2"/>
-          </p:nvPr>
-        </p:nvSpPr>
-        <p:spPr/>
-        <p:txBody>
-          <a:bodyPr/>
-          <a:lstStyle/>
           <a:p>
-            <a:endParaRPr lang="en-BE"/>
+            <a:pPr marL="0" indent="0">
+              <a:buNone/>
+            </a:pPr>
+            <a:endParaRPr lang="nl-NL" b="0" i="0" dirty="0">
+              <a:effectLst/>
+              <a:latin typeface="Google Sans"/>
+            </a:endParaRPr>
+          </a:p>
+          <a:p>
+            <a:r>
+              <a:rPr lang="nl-NL" b="1" i="0" dirty="0">
+                <a:effectLst/>
+                <a:latin typeface="Google Sans"/>
+              </a:rPr>
+              <a:t>Menu's:</a:t>
+            </a:r>
+            <a:r>
+              <a:rPr lang="nl-NL" b="0" i="0" dirty="0">
+                <a:effectLst/>
+                <a:latin typeface="Google Sans"/>
+              </a:rPr>
+              <a:t> In restaurants, om het menu op je telefoon te bekijken.</a:t>
+            </a:r>
+          </a:p>
+          <a:p>
+            <a:pPr marL="0" indent="0">
+              <a:buNone/>
+            </a:pPr>
+            <a:endParaRPr lang="nl-NL" b="0" i="0" dirty="0">
+              <a:effectLst/>
+              <a:latin typeface="Google Sans"/>
+            </a:endParaRPr>
+          </a:p>
+          <a:p>
+            <a:r>
+              <a:rPr lang="nl-NL" b="1" i="0" dirty="0">
+                <a:effectLst/>
+                <a:latin typeface="Google Sans"/>
+              </a:rPr>
+              <a:t>Tracking:</a:t>
+            </a:r>
+            <a:r>
+              <a:rPr lang="nl-NL" b="0" i="0" dirty="0">
+                <a:effectLst/>
+                <a:latin typeface="Google Sans"/>
+              </a:rPr>
+              <a:t> Voor het volgen van zendingen. </a:t>
+            </a:r>
+          </a:p>
+          <a:p>
+            <a:pPr marL="0" indent="0">
+              <a:buNone/>
+            </a:pPr>
+            <a:endParaRPr lang="nl-NL" b="0" i="0" dirty="0">
+              <a:effectLst/>
+              <a:latin typeface="Google Sans"/>
+            </a:endParaRPr>
+          </a:p>
+          <a:p>
+            <a:r>
+              <a:rPr lang="nl-NL" b="1" i="0" dirty="0">
+                <a:effectLst/>
+                <a:latin typeface="Google Sans"/>
+              </a:rPr>
+              <a:t>Contacten:</a:t>
+            </a:r>
+            <a:r>
+              <a:rPr lang="nl-NL" b="0" i="0" dirty="0">
+                <a:effectLst/>
+                <a:latin typeface="Google Sans"/>
+              </a:rPr>
+              <a:t> Om contactgegevens toe te voegen aan je telefoon.</a:t>
+            </a:r>
+          </a:p>
+          <a:p>
+            <a:endParaRPr lang="nl-NL" b="0" i="0" dirty="0">
+              <a:effectLst/>
+              <a:latin typeface="Google Sans"/>
+            </a:endParaRPr>
+          </a:p>
+          <a:p>
+            <a:r>
+              <a:rPr lang="nl-NL" b="1" i="0" dirty="0">
+                <a:effectLst/>
+                <a:latin typeface="Google Sans"/>
+              </a:rPr>
+              <a:t>Evenementen:</a:t>
+            </a:r>
+            <a:r>
+              <a:rPr lang="nl-NL" b="0" i="0" dirty="0">
+                <a:effectLst/>
+                <a:latin typeface="Google Sans"/>
+              </a:rPr>
+              <a:t> Tickets, informatie, of interactieve ervaringen. </a:t>
+            </a:r>
+          </a:p>
+          <a:p>
+            <a:endParaRPr lang="nl-NL" b="0" i="0" dirty="0">
+              <a:effectLst/>
+              <a:latin typeface="Google Sans"/>
+            </a:endParaRPr>
+          </a:p>
+          <a:p>
+            <a:r>
+              <a:rPr lang="nl-NL" b="1" i="0" dirty="0">
+                <a:effectLst/>
+                <a:latin typeface="Google Sans"/>
+              </a:rPr>
+              <a:t>Wi-Fi-toegang:</a:t>
+            </a:r>
+            <a:r>
+              <a:rPr lang="nl-NL" b="0" i="0" dirty="0">
+                <a:effectLst/>
+                <a:latin typeface="Google Sans"/>
+              </a:rPr>
+              <a:t> Direct verbinden met een Wi-Fi-netwerk.</a:t>
+            </a:r>
+          </a:p>
+          <a:p>
+            <a:endParaRPr lang="nl-NL" b="0" i="0" dirty="0">
+              <a:effectLst/>
+              <a:latin typeface="Google Sans"/>
+            </a:endParaRPr>
+          </a:p>
+          <a:p>
+            <a:r>
+              <a:rPr lang="nl-NL" dirty="0">
+                <a:latin typeface="Google Sans"/>
+              </a:rPr>
+              <a:t>...</a:t>
+            </a:r>
+            <a:endParaRPr lang="nl-NL" b="0" i="0" dirty="0">
+              <a:effectLst/>
+              <a:latin typeface="Google Sans"/>
+            </a:endParaRPr>
+          </a:p>
+          <a:p>
+            <a:endParaRPr lang="nl-NL" b="0" i="0" dirty="0">
+              <a:effectLst/>
+              <a:latin typeface="Google Sans"/>
+            </a:endParaRPr>
+          </a:p>
+          <a:p>
+            <a:endParaRPr lang="nl-NL" b="0" i="0" dirty="0">
+              <a:effectLst/>
+              <a:latin typeface="Google Sans"/>
+            </a:endParaRPr>
+          </a:p>
+          <a:p>
+            <a:endParaRPr lang="en-BE" dirty="0"/>
           </a:p>
         </p:txBody>
       </p:sp>
@@ -16125,7 +16522,7 @@
           <a:p>
             <a:r>
               <a:rPr lang="en-GB" dirty="0"/>
-              <a:t>hoe word </a:t>
+              <a:t>Hoe word </a:t>
             </a:r>
             <a:r>
               <a:rPr lang="en-GB" dirty="0" err="1"/>
@@ -16168,7 +16565,33 @@
           <a:bodyPr/>
           <a:lstStyle/>
           <a:p>
-            <a:endParaRPr lang="en-BE"/>
+            <a:r>
+              <a:rPr lang="en-GB" dirty="0" err="1"/>
+              <a:t>Scannen</a:t>
+            </a:r>
+            <a:r>
+              <a:rPr lang="en-GB" dirty="0"/>
+              <a:t> , </a:t>
+            </a:r>
+            <a:r>
+              <a:rPr lang="en-GB" dirty="0" err="1"/>
+              <a:t>lezen</a:t>
+            </a:r>
+            <a:r>
+              <a:rPr lang="en-GB" dirty="0"/>
+              <a:t> ,</a:t>
+            </a:r>
+            <a:r>
+              <a:rPr lang="en-GB" dirty="0" err="1"/>
+              <a:t>actie</a:t>
+            </a:r>
+            <a:r>
+              <a:rPr lang="en-GB" dirty="0"/>
+              <a:t>.</a:t>
+            </a:r>
+          </a:p>
+          <a:p>
+            <a:endParaRPr lang="en-BE" dirty="0"/>
           </a:p>
         </p:txBody>
       </p:sp>

</xml_diff>